<commit_message>
Drop the singular-verb point from the furniture slide
Slide 22 of 冠詞 Part 2 now keeps three points: a word for furniture
as a group, no a and no s, and "a piece of furniture" for one item.

Co-Authored-By: Claude Opus 5.5 <noreply@anthropic.com>
Claude-Session: https://claude.ai/code/session_01AdzV2rtokspoPMcfpFKx4K
</commit_message>
<xml_diff>
--- a/matome/articles-2/articles-2-slides.pptx
+++ b/matome/articles-2/articles-2-slides.pptx
@@ -13724,11 +13724,11 @@
         <p:spPr>
           <a:xfrm>
             <a:off x="5943600" y="1990725"/>
-            <a:ext cx="5562600" cy="1028700"/>
+            <a:ext cx="5562600" cy="1409700"/>
           </a:xfrm>
           <a:prstGeom prst="roundRect">
             <a:avLst>
-              <a:gd name="adj" fmla="val 25926"/>
+              <a:gd name="adj" fmla="val 18919"/>
             </a:avLst>
           </a:prstGeom>
           <a:solidFill>
@@ -13752,7 +13752,7 @@
         </p:nvSpPr>
         <p:spPr>
           <a:xfrm>
-            <a:off x="6153150" y="2324100"/>
+            <a:off x="6153150" y="2514600"/>
             <a:ext cx="361950" cy="361950"/>
           </a:xfrm>
           <a:prstGeom prst="ellipse">
@@ -13772,7 +13772,7 @@
         </p:nvSpPr>
         <p:spPr>
           <a:xfrm>
-            <a:off x="6124575" y="2381250"/>
+            <a:off x="6124575" y="2571750"/>
             <a:ext cx="419100" cy="238125"/>
           </a:xfrm>
           <a:prstGeom prst="rect">
@@ -13807,7 +13807,7 @@
         </p:nvSpPr>
         <p:spPr>
           <a:xfrm>
-            <a:off x="6648450" y="2219325"/>
+            <a:off x="6648450" y="2409825"/>
             <a:ext cx="2971800" cy="276225"/>
           </a:xfrm>
           <a:prstGeom prst="rect">
@@ -13864,7 +13864,7 @@
         </p:nvSpPr>
         <p:spPr>
           <a:xfrm>
-            <a:off x="6648450" y="2505075"/>
+            <a:off x="6648450" y="2695575"/>
             <a:ext cx="5095875" cy="276225"/>
           </a:xfrm>
           <a:prstGeom prst="rect">
@@ -13899,12 +13899,12 @@
         </p:nvSpPr>
         <p:spPr>
           <a:xfrm>
-            <a:off x="5943600" y="3133725"/>
-            <a:ext cx="5562600" cy="1028700"/>
+            <a:off x="5943600" y="3514725"/>
+            <a:ext cx="5562600" cy="1409700"/>
           </a:xfrm>
           <a:prstGeom prst="roundRect">
             <a:avLst>
-              <a:gd name="adj" fmla="val 25926"/>
+              <a:gd name="adj" fmla="val 18919"/>
             </a:avLst>
           </a:prstGeom>
           <a:solidFill>
@@ -13928,7 +13928,7 @@
         </p:nvSpPr>
         <p:spPr>
           <a:xfrm>
-            <a:off x="6153150" y="3467100"/>
+            <a:off x="6153150" y="4038600"/>
             <a:ext cx="361950" cy="361950"/>
           </a:xfrm>
           <a:prstGeom prst="ellipse">
@@ -13948,7 +13948,7 @@
         </p:nvSpPr>
         <p:spPr>
           <a:xfrm>
-            <a:off x="6105525" y="3514725"/>
+            <a:off x="6105525" y="4086225"/>
             <a:ext cx="466725" cy="238125"/>
           </a:xfrm>
           <a:prstGeom prst="rect">
@@ -13983,7 +13983,7 @@
         </p:nvSpPr>
         <p:spPr>
           <a:xfrm>
-            <a:off x="6648450" y="3352800"/>
+            <a:off x="6648450" y="3924300"/>
             <a:ext cx="4676775" cy="276225"/>
           </a:xfrm>
           <a:prstGeom prst="rect">
@@ -14062,7 +14062,7 @@
         </p:nvSpPr>
         <p:spPr>
           <a:xfrm>
-            <a:off x="6648450" y="3676650"/>
+            <a:off x="6648450" y="4248150"/>
             <a:ext cx="3105150" cy="247650"/>
           </a:xfrm>
           <a:prstGeom prst="rect">
@@ -14097,12 +14097,12 @@
         </p:nvSpPr>
         <p:spPr>
           <a:xfrm>
-            <a:off x="5943600" y="4276725"/>
-            <a:ext cx="5562600" cy="1028700"/>
+            <a:off x="5943600" y="5029200"/>
+            <a:ext cx="5562600" cy="1409700"/>
           </a:xfrm>
           <a:prstGeom prst="roundRect">
             <a:avLst>
-              <a:gd name="adj" fmla="val 25926"/>
+              <a:gd name="adj" fmla="val 18919"/>
             </a:avLst>
           </a:prstGeom>
           <a:solidFill>
@@ -14126,7 +14126,7 @@
         </p:nvSpPr>
         <p:spPr>
           <a:xfrm>
-            <a:off x="6153150" y="4600575"/>
+            <a:off x="6153150" y="5553075"/>
             <a:ext cx="361950" cy="361950"/>
           </a:xfrm>
           <a:prstGeom prst="ellipse">
@@ -14146,7 +14146,7 @@
         </p:nvSpPr>
         <p:spPr>
           <a:xfrm>
-            <a:off x="6105525" y="4657725"/>
+            <a:off x="6105525" y="5610225"/>
             <a:ext cx="466725" cy="238125"/>
           </a:xfrm>
           <a:prstGeom prst="rect">
@@ -14181,7 +14181,7 @@
         </p:nvSpPr>
         <p:spPr>
           <a:xfrm>
-            <a:off x="6648450" y="4495800"/>
+            <a:off x="6648450" y="5448300"/>
             <a:ext cx="2657475" cy="276225"/>
           </a:xfrm>
           <a:prstGeom prst="rect">
@@ -14216,7 +14216,7 @@
         </p:nvSpPr>
         <p:spPr>
           <a:xfrm>
-            <a:off x="6648450" y="4781550"/>
+            <a:off x="6648450" y="5734050"/>
             <a:ext cx="3581400" cy="276225"/>
           </a:xfrm>
           <a:prstGeom prst="rect">
@@ -14250,196 +14250,6 @@
                 <a:ea typeface="Noto Sans JP"/>
               </a:rPr>
               <a:t>（家具1点）</a:t>
-            </a:r>
-          </a:p>
-        </p:txBody>
-      </p:sp>
-      <p:sp>
-        <p:nvSpPr>
-          <p:cNvPr id="35" name=""/>
-          <p:cNvSpPr/>
-          <p:nvPr/>
-        </p:nvSpPr>
-        <p:spPr>
-          <a:xfrm>
-            <a:off x="5943600" y="5410200"/>
-            <a:ext cx="5562600" cy="1028700"/>
-          </a:xfrm>
-          <a:prstGeom prst="roundRect">
-            <a:avLst>
-              <a:gd name="adj" fmla="val 25926"/>
-            </a:avLst>
-          </a:prstGeom>
-          <a:solidFill>
-            <a:srgbClr val="FFFFFF"/>
-          </a:solidFill>
-          <a:ln/>
-          <a:effectLst>
-            <a:outerShdw sx="100000" sy="100000" kx="0" ky="0" algn="bl" rotWithShape="0" blurRad="152400" dist="50800" dir="5400000">
-              <a:srgbClr val="22304A">
-                <a:alpha val="10000"/>
-              </a:srgbClr>
-            </a:outerShdw>
-          </a:effectLst>
-        </p:spPr>
-      </p:sp>
-      <p:sp>
-        <p:nvSpPr>
-          <p:cNvPr id="36" name=""/>
-          <p:cNvSpPr/>
-          <p:nvPr/>
-        </p:nvSpPr>
-        <p:spPr>
-          <a:xfrm>
-            <a:off x="6153150" y="5743575"/>
-            <a:ext cx="361950" cy="361950"/>
-          </a:xfrm>
-          <a:prstGeom prst="ellipse">
-            <a:avLst/>
-          </a:prstGeom>
-          <a:solidFill>
-            <a:srgbClr val="E8461E"/>
-          </a:solidFill>
-          <a:ln/>
-        </p:spPr>
-      </p:sp>
-      <p:sp>
-        <p:nvSpPr>
-          <p:cNvPr id="37" name=""/>
-          <p:cNvSpPr txBox="1"/>
-          <p:nvPr/>
-        </p:nvSpPr>
-        <p:spPr>
-          <a:xfrm>
-            <a:off x="6105525" y="5800725"/>
-            <a:ext cx="476250" cy="238125"/>
-          </a:xfrm>
-          <a:prstGeom prst="rect">
-            <a:avLst/>
-          </a:prstGeom>
-          <a:noFill/>
-          <a:ln/>
-        </p:spPr>
-        <p:txBody>
-          <a:bodyPr wrap="square" lIns="0" tIns="0" rIns="0" bIns="0" anchor="ctr"/>
-          <a:lstStyle/>
-          <a:p>
-            <a:pPr algn="ctr"/>
-            <a:r>
-              <a:rPr sz="1450" b="1">
-                <a:solidFill>
-                  <a:srgbClr val="FFFFFF"/>
-                </a:solidFill>
-                <a:latin typeface="DM Sans"/>
-                <a:ea typeface="DM Sans"/>
-              </a:rPr>
-              <a:t>4</a:t>
-            </a:r>
-          </a:p>
-        </p:txBody>
-      </p:sp>
-      <p:sp>
-        <p:nvSpPr>
-          <p:cNvPr id="38" name=""/>
-          <p:cNvSpPr txBox="1"/>
-          <p:nvPr/>
-        </p:nvSpPr>
-        <p:spPr>
-          <a:xfrm>
-            <a:off x="6648450" y="5638800"/>
-            <a:ext cx="2314575" cy="276225"/>
-          </a:xfrm>
-          <a:prstGeom prst="rect">
-            <a:avLst/>
-          </a:prstGeom>
-          <a:noFill/>
-          <a:ln/>
-        </p:spPr>
-        <p:txBody>
-          <a:bodyPr wrap="square" lIns="0" tIns="0" rIns="0" bIns="0" anchor="ctr"/>
-          <a:lstStyle/>
-          <a:p>
-            <a:pPr/>
-            <a:r>
-              <a:rPr sz="1500">
-                <a:solidFill>
-                  <a:srgbClr val="1C2340"/>
-                </a:solidFill>
-                <a:latin typeface="Noto Sans JP"/>
-                <a:ea typeface="Noto Sans JP"/>
-              </a:rPr>
-              <a:t>動詞は単数あつかい</a:t>
-            </a:r>
-          </a:p>
-        </p:txBody>
-      </p:sp>
-      <p:sp>
-        <p:nvSpPr>
-          <p:cNvPr id="39" name=""/>
-          <p:cNvSpPr txBox="1"/>
-          <p:nvPr/>
-        </p:nvSpPr>
-        <p:spPr>
-          <a:xfrm>
-            <a:off x="6648450" y="5924550"/>
-            <a:ext cx="4695825" cy="276225"/>
-          </a:xfrm>
-          <a:prstGeom prst="rect">
-            <a:avLst/>
-          </a:prstGeom>
-          <a:noFill/>
-          <a:ln/>
-        </p:spPr>
-        <p:txBody>
-          <a:bodyPr wrap="square" lIns="0" tIns="0" rIns="0" bIns="0" anchor="ctr"/>
-          <a:lstStyle/>
-          <a:p>
-            <a:pPr/>
-            <a:r>
-              <a:rPr sz="1500" b="1">
-                <a:solidFill>
-                  <a:srgbClr val="1C2340"/>
-                </a:solidFill>
-                <a:latin typeface="DM Sans"/>
-                <a:ea typeface="DM Sans"/>
-              </a:rPr>
-              <a:t>The furniture </a:t>
-            </a:r>
-            <a:pPr/>
-            <a:r>
-              <a:rPr sz="1500" b="1">
-                <a:solidFill>
-                  <a:srgbClr val="1C2340"/>
-                </a:solidFill>
-                <a:highlight>
-                  <a:srgbClr val="FFD9C9"/>
-                </a:highlight>
-                <a:latin typeface="DM Sans"/>
-                <a:ea typeface="DM Sans"/>
-              </a:rPr>
-              <a:t>is</a:t>
-            </a:r>
-            <a:pPr/>
-            <a:r>
-              <a:rPr sz="1500" b="1">
-                <a:solidFill>
-                  <a:srgbClr val="1C2340"/>
-                </a:solidFill>
-                <a:latin typeface="DM Sans"/>
-                <a:ea typeface="DM Sans"/>
-              </a:rPr>
-              <a:t> new.</a:t>
-            </a:r>
-            <a:pPr/>
-            <a:r>
-              <a:rPr sz="1500">
-                <a:solidFill>
-                  <a:srgbClr val="1C2340"/>
-                </a:solidFill>
-                <a:latin typeface="Noto Sans JP"/>
-                <a:ea typeface="Noto Sans JP"/>
-              </a:rPr>
-              <a:t>（その家具は新しい）</a:t>
             </a:r>
           </a:p>
         </p:txBody>

</xml_diff>